<commit_message>
Build FreeP PowerPoint COM baseline
</commit_message>
<xml_diff>
--- a/tools/FreeP.RenderCompare/corpus/10-motionpath.pptx
+++ b/tools/FreeP.RenderCompare/corpus/10-motionpath.pptx
@@ -184,10 +184,13 @@
       </p:sp>
     </p:spTree>
   </p:cSld>
+  <p:clrMapOvr>
+    <a:masterClrMapping/>
+  </p:clrMapOvr>
   <p:timing>
     <p:tnLst>
       <p:par>
-        <p:cTn id="11" fill="hold">
+        <p:cTn id="17" fill="hold">
           <p:stCondLst>
             <p:cond delay="0"/>
           </p:stCondLst>
@@ -291,58 +294,53 @@
                 </p:childTnLst>
               </p:cTn>
             </p:par>
-          </p:childTnLst>
-        </p:cTn>
-      </p:par>
-      <p:par>
-        <p:cTn id="18" fill="hold">
-          <p:stCondLst>
-            <p:cond delay="0"/>
-          </p:stCondLst>
-          <p:childTnLst>
-            <p:seq concurrent="1" nextAc="seek">
-              <p:cTn id="17" dur="indefinite" nodeType="interactiveSeq">
+            <p:par>
+              <p:cTn id="16" fill="hold">
                 <p:stCondLst>
-                  <p:cond evt="onClick" delay="0">
-                    <p:tgtEl>
-                      <p:spTgt spid="4"/>
-                    </p:tgtEl>
-                  </p:cond>
+                  <p:cond delay="0"/>
                 </p:stCondLst>
                 <p:childTnLst>
-                  <p:par>
-                    <p:cTn id="16" fill="hold">
+                  <p:seq concurrent="1" nextAc="seek">
+                    <p:cTn id="15" dur="indefinite" nodeType="interactiveSeq">
                       <p:stCondLst>
                         <p:cond evt="onClick" delay="0">
-                          <p:tn val="0"/>
+                          <p:tgtEl>
+                            <p:spTgt spid="4"/>
+                          </p:tgtEl>
                         </p:cond>
                       </p:stCondLst>
                       <p:childTnLst>
                         <p:par>
-                          <p:cTn id="12" presetClass="entr" presetID="1" presetSubtype="0" fill="hold" grpId="0" nodeType="withEffect">
+                          <p:cTn id="14" fill="hold">
                             <p:stCondLst>
-                              <p:cond delay="indefinite"/>
+                              <p:cond evt="onClick" delay="0">
+                                <p:tn val="0"/>
+                              </p:cond>
                             </p:stCondLst>
                             <p:childTnLst>
                               <p:par>
-                                <p:cTn id="15" fill="hold">
+                                <p:cTn id="11" presetClass="entr" presetID="1" presetSubtype="0" fill="hold" grpId="0" nodeType="withEffect">
                                   <p:stCondLst>
-                                    <p:cond delay="0"/>
+                                    <p:cond delay="indefinite"/>
                                   </p:stCondLst>
                                   <p:childTnLst>
-                                    <p:cTn id="13" dur="500">
-                                      <p:stCondLst>
-                                        <p:cond delay="0"/>
-                                      </p:stCondLst>
-                                    </p:cTn>
-                                    <p:set>
-                                      <p:cBhvr>
-                                        <p:cTn id="14" dur="1" fill="hold"/>
-                                        <p:tgtEl>
-                                          <p:spTgt spid="5"/>
-                                        </p:tgtEl>
-                                      </p:cBhvr>
-                                    </p:set>
+                                    <p:par>
+                                      <p:cTn id="13" fill="hold">
+                                        <p:stCondLst>
+                                          <p:cond delay="0"/>
+                                        </p:stCondLst>
+                                        <p:childTnLst>
+                                          <p:set>
+                                            <p:cBhvr>
+                                              <p:cTn id="12" dur="1" fill="hold"/>
+                                              <p:tgtEl>
+                                                <p:spTgt spid="5"/>
+                                              </p:tgtEl>
+                                            </p:cBhvr>
+                                          </p:set>
+                                        </p:childTnLst>
+                                      </p:cTn>
+                                    </p:par>
                                   </p:childTnLst>
                                 </p:cTn>
                               </p:par>
@@ -351,10 +349,10 @@
                         </p:par>
                       </p:childTnLst>
                     </p:cTn>
-                  </p:par>
+                  </p:seq>
                 </p:childTnLst>
               </p:cTn>
-            </p:seq>
+            </p:par>
           </p:childTnLst>
         </p:cTn>
       </p:par>
@@ -407,9 +405,13 @@
     <a:fontScheme name="Office Theme">
       <a:majorFont>
         <a:latin typeface="Calibri Light"/>
+        <a:ea typeface=""/>
+        <a:cs typeface=""/>
       </a:majorFont>
       <a:minorFont>
         <a:latin typeface="Calibri"/>
+        <a:ea typeface=""/>
+        <a:cs typeface=""/>
       </a:minorFont>
     </a:fontScheme>
     <a:fmtScheme name="Office">

</xml_diff>

<commit_message>
Fix PowerPoint repair-dialog corpus packages
</commit_message>
<xml_diff>
--- a/tools/FreeP.RenderCompare/corpus/10-motionpath.pptx
+++ b/tools/FreeP.RenderCompare/corpus/10-motionpath.pptx
@@ -9,6 +9,101 @@
   </p:sldIdLst>
   <p:sldSz cx="12192000" cy="6858000" type="screen16x9"/>
   <p:notesSz cx="6858000" cy="9144000"/>
+  <p:defaultTextStyle>
+    <a:defPPr>
+      <a:defRPr lang="en-US"/>
+    </a:defPPr>
+    <a:lvl1pPr marL="0" algn="l" defTabSz="914400" rtl="0" eaLnBrk="1" latinLnBrk="0" hangingPunct="1">
+      <a:defRPr sz="1800" kern="1200">
+        <a:solidFill>
+          <a:schemeClr val="tx1"/>
+        </a:solidFill>
+        <a:latin typeface="+mn-lt"/>
+        <a:ea typeface="+mn-ea"/>
+        <a:cs typeface="+mn-cs"/>
+      </a:defRPr>
+    </a:lvl1pPr>
+    <a:lvl2pPr marL="457200" algn="l" defTabSz="914400" rtl="0" eaLnBrk="1" latinLnBrk="0" hangingPunct="1">
+      <a:defRPr sz="1800" kern="1200">
+        <a:solidFill>
+          <a:schemeClr val="tx1"/>
+        </a:solidFill>
+        <a:latin typeface="+mn-lt"/>
+        <a:ea typeface="+mn-ea"/>
+        <a:cs typeface="+mn-cs"/>
+      </a:defRPr>
+    </a:lvl2pPr>
+    <a:lvl3pPr marL="914400" algn="l" defTabSz="914400" rtl="0" eaLnBrk="1" latinLnBrk="0" hangingPunct="1">
+      <a:defRPr sz="1800" kern="1200">
+        <a:solidFill>
+          <a:schemeClr val="tx1"/>
+        </a:solidFill>
+        <a:latin typeface="+mn-lt"/>
+        <a:ea typeface="+mn-ea"/>
+        <a:cs typeface="+mn-cs"/>
+      </a:defRPr>
+    </a:lvl3pPr>
+    <a:lvl4pPr marL="1371600" algn="l" defTabSz="914400" rtl="0" eaLnBrk="1" latinLnBrk="0" hangingPunct="1">
+      <a:defRPr sz="1800" kern="1200">
+        <a:solidFill>
+          <a:schemeClr val="tx1"/>
+        </a:solidFill>
+        <a:latin typeface="+mn-lt"/>
+        <a:ea typeface="+mn-ea"/>
+        <a:cs typeface="+mn-cs"/>
+      </a:defRPr>
+    </a:lvl4pPr>
+    <a:lvl5pPr marL="1828800" algn="l" defTabSz="914400" rtl="0" eaLnBrk="1" latinLnBrk="0" hangingPunct="1">
+      <a:defRPr sz="1800" kern="1200">
+        <a:solidFill>
+          <a:schemeClr val="tx1"/>
+        </a:solidFill>
+        <a:latin typeface="+mn-lt"/>
+        <a:ea typeface="+mn-ea"/>
+        <a:cs typeface="+mn-cs"/>
+      </a:defRPr>
+    </a:lvl5pPr>
+    <a:lvl6pPr marL="2286000" algn="l" defTabSz="914400" rtl="0" eaLnBrk="1" latinLnBrk="0" hangingPunct="1">
+      <a:defRPr sz="1800" kern="1200">
+        <a:solidFill>
+          <a:schemeClr val="tx1"/>
+        </a:solidFill>
+        <a:latin typeface="+mn-lt"/>
+        <a:ea typeface="+mn-ea"/>
+        <a:cs typeface="+mn-cs"/>
+      </a:defRPr>
+    </a:lvl6pPr>
+    <a:lvl7pPr marL="2743200" algn="l" defTabSz="914400" rtl="0" eaLnBrk="1" latinLnBrk="0" hangingPunct="1">
+      <a:defRPr sz="1800" kern="1200">
+        <a:solidFill>
+          <a:schemeClr val="tx1"/>
+        </a:solidFill>
+        <a:latin typeface="+mn-lt"/>
+        <a:ea typeface="+mn-ea"/>
+        <a:cs typeface="+mn-cs"/>
+      </a:defRPr>
+    </a:lvl7pPr>
+    <a:lvl8pPr marL="3200400" algn="l" defTabSz="914400" rtl="0" eaLnBrk="1" latinLnBrk="0" hangingPunct="1">
+      <a:defRPr sz="1800" kern="1200">
+        <a:solidFill>
+          <a:schemeClr val="tx1"/>
+        </a:solidFill>
+        <a:latin typeface="+mn-lt"/>
+        <a:ea typeface="+mn-ea"/>
+        <a:cs typeface="+mn-cs"/>
+      </a:defRPr>
+    </a:lvl8pPr>
+    <a:lvl9pPr marL="3657600" algn="l" defTabSz="914400" rtl="0" eaLnBrk="1" latinLnBrk="0" hangingPunct="1">
+      <a:defRPr sz="1800" kern="1200">
+        <a:solidFill>
+          <a:schemeClr val="tx1"/>
+        </a:solidFill>
+        <a:latin typeface="+mn-lt"/>
+        <a:ea typeface="+mn-ea"/>
+        <a:cs typeface="+mn-cs"/>
+      </a:defRPr>
+    </a:lvl9pPr>
+  </p:defaultTextStyle>
 </p:presentation>
 </file>
 
@@ -190,7 +285,7 @@
   <p:timing>
     <p:tnLst>
       <p:par>
-        <p:cTn id="17" fill="hold">
+        <p:cTn id="17" dur="indefinite" restart="never" fill="hold" nodeType="tmRoot">
           <p:stCondLst>
             <p:cond delay="0"/>
           </p:stCondLst>
@@ -319,7 +414,7 @@
                             </p:stCondLst>
                             <p:childTnLst>
                               <p:par>
-                                <p:cTn id="11" presetClass="entr" presetID="1" presetSubtype="0" fill="hold" grpId="0" nodeType="withEffect">
+                                <p:cTn id="11" presetClass="entr" presetID="1" presetSubtype="0" dur="500" fill="hold" grpId="0" nodeType="withEffect">
                                   <p:stCondLst>
                                     <p:cond delay="indefinite"/>
                                   </p:stCondLst>

</xml_diff>